<commit_message>
docs: MAIN_JOIN_02·MAIN_CHAT_02 콜아웃 위치 정리, SD-09 반영
시안을 최신본으로 갈아끼우면서 콜아웃 표시가 옛 화면 기준 좌표에 남아
엉뚱한 곳을 가리키던 것을 마무리했습니다.

## MAIN_JOIN_02

마커 7개를 새 시안의 입력 필드 위치로 옮겼습니다.
이메일 · 비밀번호 · 중복확인 버튼 · 이름 · 생년월일/키 · 성별 · 연락처.

⚠ 문안에는 ❽(회원가입 완료 버튼)이 있는데 **그림 위 표시가 없었습니다.**
❼ 도형을 복제해 회원가입 완료 버튼 위에 신설했습니다.

SD-09 도 같이 반영했습니다. 시안에는 「키 · 선택」 필드가 이미 그려져
있는데 문안에만 빠져 있었습니다. 지금까지와 같은 패턴입니다.
  개정 전: 사용자 인적사항: 이름, 생년월일, 성별 입력
  개정 후: 사용자 인적사항: 이름, 생년월일, 성별, 키(선택) 입력

## MAIN_CHAT_02

❸(대화 글자 및 음성 입력)이 입력창보다 한참 위 빈 공간에 떠 있었고,
❹(대화 종료)는 그림 오른쪽 밖으로 나가 잘려 보였습니다. 둘 다 맞췄습니다.

## 이제 이미지 위 콜아웃이 있는 5장이 모두 정리됐습니다

  MAIN_LOGIN_01  원래 맞음
  MAIN_JOIN_01   SD-A③ 과 함께 재배치
  MAIN_CHAT_01   시안 2장 -> 1장 변경분 재배치
  MAIN_JOIN_02   이번
  MAIN_CHAT_02   이번

PowerPoint 로 열어 렌더링으로 확인했습니다.

Co-Authored-By: Claude Opus 5 <noreply@anthropic.com>
</commit_message>
<xml_diff>
--- a/Documents/화면설계서_귀기울임.pptx
+++ b/Documents/화면설계서_귀기울임.pptx
@@ -18646,7 +18646,7 @@
         </p:nvSpPr>
         <p:spPr>
           <a:xfrm>
-            <a:off x="5091792" y="4155167"/>
+            <a:off x="5184743" y="4723810"/>
             <a:ext cx="266700" cy="272415"/>
           </a:xfrm>
           <a:prstGeom prst="rect">
@@ -18697,7 +18697,7 @@
         </p:nvSpPr>
         <p:spPr>
           <a:xfrm>
-            <a:off x="7282537" y="94189"/>
+            <a:off x="7137371" y="55810"/>
             <a:ext cx="266700" cy="267970"/>
           </a:xfrm>
           <a:prstGeom prst="rect">
@@ -47032,7 +47032,7 @@
                 <a:cs typeface="맑은 고딕"/>
                 <a:sym typeface="맑은 고딕"/>
               </a:rPr>
-              <a:t> 사용자 인적사항: 이름, 생년월일, 성별 입력</a:t>
+              <a:t> 사용자 인적사항: 이름, 생년월일, 성별, 키(선택) 입력</a:t>
             </a:r>
           </a:p>
           <a:p>
@@ -48121,7 +48121,7 @@
         </p:nvSpPr>
         <p:spPr>
           <a:xfrm>
-            <a:off x="5048250" y="1246714"/>
+            <a:off x="5184743" y="961951"/>
             <a:ext cx="266700" cy="264795"/>
           </a:xfrm>
           <a:prstGeom prst="rect">
@@ -48172,7 +48172,7 @@
         </p:nvSpPr>
         <p:spPr>
           <a:xfrm>
-            <a:off x="5048250" y="1793240"/>
+            <a:off x="5184743" y="1651473"/>
             <a:ext cx="266700" cy="266700"/>
           </a:xfrm>
           <a:prstGeom prst="rect">
@@ -48223,7 +48223,7 @@
         </p:nvSpPr>
         <p:spPr>
           <a:xfrm>
-            <a:off x="5048250" y="2339975"/>
+            <a:off x="5184743" y="2344046"/>
             <a:ext cx="266700" cy="267970"/>
           </a:xfrm>
           <a:prstGeom prst="rect">
@@ -48274,7 +48274,7 @@
         </p:nvSpPr>
         <p:spPr>
           <a:xfrm>
-            <a:off x="5048250" y="2873375"/>
+            <a:off x="5184743" y="2804744"/>
             <a:ext cx="266700" cy="267970"/>
           </a:xfrm>
           <a:prstGeom prst="rect">
@@ -48325,7 +48325,7 @@
         </p:nvSpPr>
         <p:spPr>
           <a:xfrm>
-            <a:off x="5048250" y="3368675"/>
+            <a:off x="5184743" y="3262391"/>
             <a:ext cx="266700" cy="267970"/>
           </a:xfrm>
           <a:prstGeom prst="rect">
@@ -48376,7 +48376,7 @@
         </p:nvSpPr>
         <p:spPr>
           <a:xfrm>
-            <a:off x="5048250" y="3916680"/>
+            <a:off x="5184743" y="3726140"/>
             <a:ext cx="266700" cy="272415"/>
           </a:xfrm>
           <a:prstGeom prst="rect">
@@ -48427,7 +48427,7 @@
         </p:nvSpPr>
         <p:spPr>
           <a:xfrm>
-            <a:off x="6581775" y="1246714"/>
+            <a:off x="6984822" y="961951"/>
             <a:ext cx="266700" cy="272415"/>
           </a:xfrm>
           <a:prstGeom prst="rect">
@@ -48465,6 +48465,57 @@
                 <a:sym typeface="맑은 고딕"/>
               </a:rPr>
               <a:t>❸</a:t>
+            </a:r>
+            <a:endParaRPr lang="ko-KR" altLang="en-US"/>
+          </a:p>
+        </p:txBody>
+      </p:sp>
+      <p:sp>
+        <p:nvSpPr>
+          <p:cNvPr id="296" name="가로 글상자 296"/>
+          <p:cNvSpPr txBox="1"/>
+          <p:nvPr/>
+        </p:nvSpPr>
+        <p:spPr>
+          <a:xfrm>
+            <a:off x="5184743" y="4110563"/>
+            <a:ext cx="266700" cy="272415"/>
+          </a:xfrm>
+          <a:prstGeom prst="rect">
+            <a:avLst/>
+          </a:prstGeom>
+        </p:spPr>
+        <p:txBody>
+          <a:bodyPr wrap="square">
+            <a:spAutoFit/>
+          </a:bodyPr>
+          <a:lstStyle/>
+          <a:p>
+            <a:pPr marL="0" marR="0" lvl="0" indent="0" algn="l" rtl="0">
+              <a:spcBef>
+                <a:spcPts val="0"/>
+              </a:spcBef>
+              <a:spcAft>
+                <a:spcPts val="0"/>
+              </a:spcAft>
+              <a:buClr>
+                <a:srgbClr val="31333F"/>
+              </a:buClr>
+              <a:buSzPct val="25000"/>
+              <a:buFont typeface="맑은 고딕"/>
+              <a:buNone/>
+              <a:defRPr/>
+            </a:pPr>
+            <a:r>
+              <a:rPr lang="ko-KR" sz="1200" b="0" i="0">
+                <a:solidFill>
+                  <a:srgbClr val="31333F"/>
+                </a:solidFill>
+                <a:latin typeface="맑은 고딕"/>
+                <a:cs typeface="맑은 고딕"/>
+                <a:sym typeface="맑은 고딕"/>
+              </a:rPr>
+              <a:t>❽</a:t>
             </a:r>
             <a:endParaRPr lang="ko-KR" altLang="en-US"/>
           </a:p>

</xml_diff>